<commit_message>
Update Coordinating Multiple Tasks
</commit_message>
<xml_diff>
--- a/6. Coordinating Multiple Tasks/CoordinatingTasks.pptx
+++ b/6. Coordinating Multiple Tasks/CoordinatingTasks.pptx
@@ -255,7 +255,7 @@
               <a:rPr lang="en-US" smtClean="0">
                 <a:latin typeface="Segoe UI" pitchFamily="34" charset="0"/>
               </a:rPr>
-              <a:t>9/7/26 12:07 PM</a:t>
+              <a:t>9/12/26 4:47 PM</a:t>
             </a:fld>
             <a:endParaRPr lang="en-US">
               <a:latin typeface="Segoe UI" pitchFamily="34" charset="0"/>
@@ -533,7 +533,7 @@
           <a:p>
             <a:fld id="{D18B56EA-E28F-4F92-9F16-7A6F2501B303}" type="datetime8">
               <a:rPr lang="en-US" smtClean="0"/>
-              <a:t>9/7/26 12:07 PM</a:t>
+              <a:t>9/12/26 4:47 PM</a:t>
             </a:fld>
             <a:endParaRPr lang="en-US"/>
           </a:p>
@@ -7827,7 +7827,12 @@
             <p:ph type="title"/>
           </p:nvPr>
         </p:nvSpPr>
-        <p:spPr/>
+        <p:spPr>
+          <a:xfrm>
+            <a:off x="274701" y="2742366"/>
+            <a:ext cx="9143936" cy="1828786"/>
+          </a:xfrm>
+        </p:spPr>
         <p:txBody>
           <a:bodyPr/>
           <a:lstStyle/>
@@ -7835,13 +7840,6 @@
             <a:r>
               <a:rPr lang="en-US" sz="4000" dirty="0"/>
               <a:t>Coordinating Multiple Tasks</a:t>
-            </a:r>
-            <a:br>
-              <a:rPr lang="en-US" sz="4000" dirty="0"/>
-            </a:br>
-            <a:r>
-              <a:rPr lang="en-US" sz="4000" dirty="0"/>
-              <a:t>Task.WhenAll, Task.WhenAny, Task.WhenEach</a:t>
             </a:r>
           </a:p>
         </p:txBody>
@@ -8063,13 +8061,18 @@
             <p:ph type="title"/>
           </p:nvPr>
         </p:nvSpPr>
-        <p:spPr/>
+        <p:spPr>
+          <a:xfrm>
+            <a:off x="274638" y="2125662"/>
+            <a:ext cx="5638799" cy="1098762"/>
+          </a:xfrm>
+        </p:spPr>
         <p:txBody>
           <a:bodyPr/>
           <a:lstStyle/>
           <a:p>
             <a:r>
-              <a:rPr lang="en-US" dirty="0"/>
+              <a:rPr lang="en-US" sz="6600" dirty="0"/>
               <a:t>Task.WhenEach</a:t>
             </a:r>
           </a:p>
@@ -8451,7 +8454,7 @@
         <p:spPr>
           <a:xfrm>
             <a:off x="274320" y="1627632"/>
-            <a:ext cx="11887200" cy="3065455"/>
+            <a:ext cx="11887200" cy="2930033"/>
           </a:xfrm>
         </p:spPr>
         <p:txBody>
@@ -8501,15 +8504,15 @@
           </a:p>
           <a:p>
             <a:r>
-              <a:rPr lang="en-US" sz="4000" dirty="0"/>
+              <a:rPr lang="en-US" sz="3200" dirty="0"/>
               <a:t>`</a:t>
             </a:r>
             <a:r>
-              <a:rPr lang="en-US" sz="4000" dirty="0" err="1"/>
+              <a:rPr lang="en-US" sz="3200" dirty="0" err="1"/>
               <a:t>Task.WhenEach</a:t>
             </a:r>
             <a:r>
-              <a:rPr lang="en-US" sz="4000" dirty="0"/>
+              <a:rPr lang="en-US" sz="3200" dirty="0"/>
               <a:t>`</a:t>
             </a:r>
           </a:p>
@@ -11160,6 +11163,16 @@
 </file>
 
 <file path=customXml/item1.xml><?xml version="1.0" encoding="utf-8"?>
+<p:properties xmlns:p="http://schemas.microsoft.com/office/2006/metadata/properties" xmlns:xsi="http://www.w3.org/2001/XMLSchema-instance" xmlns:pc="http://schemas.microsoft.com/office/infopath/2007/PartnerControls">
+  <documentManagement>
+    <_ip_UnifiedCompliancePolicyUIAction xmlns="http://schemas.microsoft.com/sharepoint/v3" xsi:nil="true"/>
+    <MediaServiceKeyPoints xmlns="16dc66bd-df5a-4495-a5c9-5e296f49988a" xsi:nil="true"/>
+    <_ip_UnifiedCompliancePolicyProperties xmlns="http://schemas.microsoft.com/sharepoint/v3" xsi:nil="true"/>
+  </documentManagement>
+</p:properties>
+</file>
+
+<file path=customXml/item2.xml><?xml version="1.0" encoding="utf-8"?>
 <ct:contentTypeSchema xmlns:ct="http://schemas.microsoft.com/office/2006/metadata/contentType" xmlns:ma="http://schemas.microsoft.com/office/2006/metadata/properties/metaAttributes" ct:_="" ma:_="" ma:contentTypeName="Document" ma:contentTypeID="0x010100A33D2391BFF58241AEB203BD95DC1F89" ma:contentTypeVersion="16" ma:contentTypeDescription="Create a new document." ma:contentTypeScope="" ma:versionID="bd4b5e6fa70efd11586bd069caa6259f">
   <xsd:schema xmlns:xsd="http://www.w3.org/2001/XMLSchema" xmlns:xs="http://www.w3.org/2001/XMLSchema" xmlns:p="http://schemas.microsoft.com/office/2006/metadata/properties" xmlns:ns1="http://schemas.microsoft.com/sharepoint/v3" xmlns:ns2="16dc66bd-df5a-4495-a5c9-5e296f49988a" xmlns:ns3="12239fb0-26c0-4a37-b790-6c81fba9d0fc" targetNamespace="http://schemas.microsoft.com/office/2006/metadata/properties" ma:root="true" ma:fieldsID="1236f19879e555dfdef409a5be7c6d72" ns1:_="" ns2:_="" ns3:_="">
     <xsd:import namespace="http://schemas.microsoft.com/sharepoint/v3"/>
@@ -11405,16 +11418,6 @@
 </ct:contentTypeSchema>
 </file>
 
-<file path=customXml/item2.xml><?xml version="1.0" encoding="utf-8"?>
-<p:properties xmlns:p="http://schemas.microsoft.com/office/2006/metadata/properties" xmlns:xsi="http://www.w3.org/2001/XMLSchema-instance" xmlns:pc="http://schemas.microsoft.com/office/infopath/2007/PartnerControls">
-  <documentManagement>
-    <_ip_UnifiedCompliancePolicyUIAction xmlns="http://schemas.microsoft.com/sharepoint/v3" xsi:nil="true"/>
-    <MediaServiceKeyPoints xmlns="16dc66bd-df5a-4495-a5c9-5e296f49988a" xsi:nil="true"/>
-    <_ip_UnifiedCompliancePolicyProperties xmlns="http://schemas.microsoft.com/sharepoint/v3" xsi:nil="true"/>
-  </documentManagement>
-</p:properties>
-</file>
-
 <file path=customXml/item3.xml><?xml version="1.0" encoding="utf-8"?>
 <?mso-contentType ?>
 <FormTemplates xmlns="http://schemas.microsoft.com/sharepoint/v3/contenttype/forms">
@@ -11425,6 +11428,24 @@
 </file>
 
 <file path=customXml/itemProps1.xml><?xml version="1.0" encoding="utf-8"?>
+<ds:datastoreItem xmlns:ds="http://schemas.openxmlformats.org/officeDocument/2006/customXml" ds:itemID="{B59C5458-A72E-4627-9FFC-D350DCB4700F}">
+  <ds:schemaRefs>
+    <ds:schemaRef ds:uri="http://schemas.microsoft.com/office/2006/metadata/properties"/>
+    <ds:schemaRef ds:uri="http://schemas.openxmlformats.org/package/2006/metadata/core-properties"/>
+    <ds:schemaRef ds:uri="http://purl.org/dc/dcmitype/"/>
+    <ds:schemaRef ds:uri="http://schemas.microsoft.com/office/infopath/2007/PartnerControls"/>
+    <ds:schemaRef ds:uri="http://schemas.microsoft.com/sharepoint/v3"/>
+    <ds:schemaRef ds:uri="http://purl.org/dc/elements/1.1/"/>
+    <ds:schemaRef ds:uri="http://schemas.microsoft.com/office/2006/documentManagement/types"/>
+    <ds:schemaRef ds:uri="12239fb0-26c0-4a37-b790-6c81fba9d0fc"/>
+    <ds:schemaRef ds:uri="16dc66bd-df5a-4495-a5c9-5e296f49988a"/>
+    <ds:schemaRef ds:uri="http://www.w3.org/XML/1998/namespace"/>
+    <ds:schemaRef ds:uri="http://purl.org/dc/terms/"/>
+  </ds:schemaRefs>
+</ds:datastoreItem>
+</file>
+
+<file path=customXml/itemProps2.xml><?xml version="1.0" encoding="utf-8"?>
 <ds:datastoreItem xmlns:ds="http://schemas.openxmlformats.org/officeDocument/2006/customXml" ds:itemID="{F517AA3B-FC88-46DF-B5BA-DC6634CFCC94}">
   <ds:schemaRefs>
     <ds:schemaRef ds:uri="12239fb0-26c0-4a37-b790-6c81fba9d0fc"/>
@@ -11444,24 +11465,6 @@
 </ds:datastoreItem>
 </file>
 
-<file path=customXml/itemProps2.xml><?xml version="1.0" encoding="utf-8"?>
-<ds:datastoreItem xmlns:ds="http://schemas.openxmlformats.org/officeDocument/2006/customXml" ds:itemID="{B59C5458-A72E-4627-9FFC-D350DCB4700F}">
-  <ds:schemaRefs>
-    <ds:schemaRef ds:uri="http://schemas.microsoft.com/office/2006/metadata/properties"/>
-    <ds:schemaRef ds:uri="http://schemas.openxmlformats.org/package/2006/metadata/core-properties"/>
-    <ds:schemaRef ds:uri="http://purl.org/dc/dcmitype/"/>
-    <ds:schemaRef ds:uri="http://schemas.microsoft.com/office/infopath/2007/PartnerControls"/>
-    <ds:schemaRef ds:uri="http://schemas.microsoft.com/sharepoint/v3"/>
-    <ds:schemaRef ds:uri="http://purl.org/dc/elements/1.1/"/>
-    <ds:schemaRef ds:uri="http://schemas.microsoft.com/office/2006/documentManagement/types"/>
-    <ds:schemaRef ds:uri="12239fb0-26c0-4a37-b790-6c81fba9d0fc"/>
-    <ds:schemaRef ds:uri="16dc66bd-df5a-4495-a5c9-5e296f49988a"/>
-    <ds:schemaRef ds:uri="http://www.w3.org/XML/1998/namespace"/>
-    <ds:schemaRef ds:uri="http://purl.org/dc/terms/"/>
-  </ds:schemaRefs>
-</ds:datastoreItem>
-</file>
-
 <file path=customXml/itemProps3.xml><?xml version="1.0" encoding="utf-8"?>
 <ds:datastoreItem xmlns:ds="http://schemas.openxmlformats.org/officeDocument/2006/customXml" ds:itemID="{758FDAC0-319D-4A54-8D8E-1D42CB1F8004}">
   <ds:schemaRefs>

</xml_diff>